<commit_message>
Ajout nombre de participants
</commit_message>
<xml_diff>
--- a/2-Analyse exploratoire des données/1-Speed Dating/doc/Speed_Dating_Storytelling.pptx
+++ b/2-Analyse exploratoire des données/1-Speed Dating/doc/Speed_Dating_Storytelling.pptx
@@ -142,7 +142,7 @@
     </p:spTree>
     <p:extLst>
       <p:ext uri="{BB962C8B-B14F-4D97-AF65-F5344CB8AC3E}">
-        <p14:creationId xmlns:p14="http://schemas.microsoft.com/office/powerpoint/2010/main" val="3429161829"/>
+        <p14:creationId xmlns:p14="http://schemas.microsoft.com/office/powerpoint/2010/main" val="2510152626"/>
       </p:ext>
     </p:extLst>
   </p:cSld>
@@ -1007,7 +1007,7 @@
         </p:nvSpPr>
         <p:spPr>
           <a:xfrm>
-            <a:off x="1152011" y="46721"/>
+            <a:off x="1234440" y="102870"/>
             <a:ext cx="4937760" cy="4937760"/>
           </a:xfrm>
           <a:prstGeom prst="ellipse">
@@ -1022,7 +1022,7 @@
           <a:bodyPr/>
           <a:lstStyle/>
           <a:p>
-            <a:endParaRPr lang="fr-FR"/>
+            <a:endParaRPr/>
           </a:p>
         </p:txBody>
       </p:sp>
@@ -1051,7 +1051,7 @@
           <a:bodyPr/>
           <a:lstStyle/>
           <a:p>
-            <a:endParaRPr lang="fr-FR"/>
+            <a:endParaRPr/>
           </a:p>
         </p:txBody>
       </p:sp>
@@ -1186,7 +1186,7 @@
           <a:bodyPr/>
           <a:lstStyle/>
           <a:p>
-            <a:endParaRPr lang="fr-FR"/>
+            <a:endParaRPr/>
           </a:p>
         </p:txBody>
       </p:sp>
@@ -1262,7 +1262,7 @@
                 <a:ea typeface="Calibri" pitchFamily="34" charset="-122"/>
                 <a:cs typeface="Calibri" pitchFamily="34" charset="-120"/>
               </a:rPr>
-              <a:t>Analyse des 8 378 rencontres de l'expérience Columbia University (2002-2004)</a:t>
+              <a:t>Analyse de 8 378 rencontres entre 551 participants, expérience Columbia University (2002-2004)</a:t>
             </a:r>
             <a:endParaRPr lang="en-US" sz="1150" dirty="0"/>
           </a:p>
@@ -1296,7 +1296,7 @@
           <a:bodyPr/>
           <a:lstStyle/>
           <a:p>
-            <a:endParaRPr lang="fr-FR"/>
+            <a:endParaRPr/>
           </a:p>
         </p:txBody>
       </p:sp>
@@ -1406,7 +1406,7 @@
           <a:bodyPr/>
           <a:lstStyle/>
           <a:p>
-            <a:endParaRPr lang="fr-FR"/>
+            <a:endParaRPr/>
           </a:p>
         </p:txBody>
       </p:sp>
@@ -1516,7 +1516,7 @@
           <a:bodyPr/>
           <a:lstStyle/>
           <a:p>
-            <a:endParaRPr lang="fr-FR"/>
+            <a:endParaRPr/>
           </a:p>
         </p:txBody>
       </p:sp>
@@ -7360,7 +7360,7 @@
         </p:nvSpPr>
         <p:spPr>
           <a:xfrm>
-            <a:off x="5806440" y="45720"/>
+            <a:off x="5998464" y="45720"/>
             <a:ext cx="3108960" cy="3108960"/>
           </a:xfrm>
           <a:prstGeom prst="ellipse">

</xml_diff>